<commit_message>
week 6 slide updates, report generated, top level slides generated, git ignore updated.
</commit_message>
<xml_diff>
--- a/Weekly Reports/slides/1-ethan-wells.pptx
+++ b/Weekly Reports/slides/1-ethan-wells.pptx
@@ -3415,57 +3415,42 @@
             <a:pPr lvl="1"/>
             <a:r>
               <a:rPr sz="2900" dirty="0"/>
-              <a:t>Neither machine-learning goal was started — getting the CM5 ready for hardware testing took priority so the team has a working board to bench-test sensors on.</a:t>
+              <a:t>Downloaded the LISA Traffic Signs dataset from the Kaggle mirror (the UCSD host was down).</a:t>
             </a:r>
           </a:p>
           <a:p>
             <a:pPr lvl="1"/>
             <a:r>
               <a:rPr sz="2900" dirty="0"/>
-              <a:t>Assembled the CM5 on the Compute Module 5 IO Board with the ZDE heatsink/PWM fan, CR2032 RTC cell, and 27 W USB-C power supply.</a:t>
+              <a:t>Wrote prepare_lisa.py: validates the download, crops each annotated sign, and splits the crops into TensorFlow-ready train/validation/test folders.</a:t>
             </a:r>
           </a:p>
           <a:p>
             <a:pPr lvl="1"/>
             <a:r>
               <a:rPr sz="2900" dirty="0"/>
-              <a:t>Flashed Raspberry Pi OS Lite (64-bit) to the 128 GB KIOXIA NVMe SSD and booted the CM5 from M.2.</a:t>
+              <a:t>Narrowed the 47 LISA classes to the 12 the car needs: 6,097 crops, split 4,946 / 567 / 584.</a:t>
             </a:r>
           </a:p>
           <a:p>
             <a:pPr lvl="1"/>
             <a:r>
               <a:rPr sz="2900" dirty="0"/>
-              <a:t>Brought up headless SSH over the USB Wi-Fi dongle (the CM5 has no onboard wireless).</a:t>
+              <a:t>Kept every frame of the same physical sign in one split, so near-identical images can't leak between training and testing.</a:t>
             </a:r>
           </a:p>
           <a:p>
             <a:pPr lvl="1"/>
             <a:r>
               <a:rPr sz="2900" dirty="0"/>
-              <a:t>SSH over Wi-Fi was painfully slow; traced it to the dongle’s stock driver and replaced it with a working RTL8188EUS build.</a:t>
+              <a:t>Documented the download and preparation steps in LISA_PREPARATION.md.</a:t>
             </a:r>
           </a:p>
           <a:p>
             <a:pPr lvl="1"/>
             <a:r>
               <a:rPr sz="2900" dirty="0"/>
-              <a:t>Wrote setup.sh, a one-command install of the shared software prerequisites (git, python3, pip, venv) so </a:t>
-            </a:r>
-            <a:r>
-              <a:rPr lang="en-US" sz="2900" dirty="0"/>
-              <a:t>anyone can start </a:t>
-            </a:r>
-            <a:r>
-              <a:rPr sz="2900" dirty="0"/>
-              <a:t>from the same baseline.</a:t>
-            </a:r>
-          </a:p>
-          <a:p>
-            <a:pPr lvl="1"/>
-            <a:r>
-              <a:rPr sz="2900" dirty="0"/>
-              <a:t>Purchased the remaining compute parts: NVMe SSD, USB NVMe enclosure, heatsink + PWM fan, 27 W power supply, CR2032 battery, and TP-Link Wi-Fi dongle.</a:t>
+              <a:t>Tested the GTSRB model on the 12,630-image GTSRB test set: 95.8% accuracy.</a:t>
             </a:r>
           </a:p>
           <a:p>
@@ -3479,14 +3464,7 @@
             <a:pPr lvl="1"/>
             <a:r>
               <a:rPr sz="2900" dirty="0"/>
-              <a:t>Prepare the LISA dataset (US traffic signs) for training.</a:t>
-            </a:r>
-          </a:p>
-          <a:p>
-            <a:pPr lvl="1"/>
-            <a:r>
-              <a:rPr sz="2900" dirty="0"/>
-              <a:t>Test the trained German-sign (GTSRB) model.</a:t>
+              <a:t>Train and test a CNN on the prepared LISA dataset.</a:t>
             </a:r>
           </a:p>
           <a:p>
@@ -3551,35 +3529,11 @@
           <a:lstStyle/>
           <a:p>
             <a:r>
-              <a:t>CM5 Bring-Up</a:t>
-            </a:r>
-          </a:p>
-        </p:txBody>
-      </p:sp>
-      <p:pic>
-        <p:nvPicPr>
-          <p:cNvPr id="3" name="Picture 2" descr="cm5_io_board_week5.jpg"/>
-          <p:cNvPicPr>
-            <a:picLocks noChangeAspect="1"/>
-          </p:cNvPicPr>
-          <p:nvPr/>
-        </p:nvPicPr>
-        <p:blipFill>
-          <a:blip r:embed="rId2"/>
-          <a:stretch>
-            <a:fillRect/>
-          </a:stretch>
-        </p:blipFill>
-        <p:spPr>
-          <a:xfrm>
-            <a:off x="548640" y="1737360"/>
-            <a:ext cx="5277040" cy="4114800"/>
-          </a:xfrm>
-          <a:prstGeom prst="rect">
-            <a:avLst/>
-          </a:prstGeom>
-        </p:spPr>
-      </p:pic>
+              <a:t>LISA Dataset Preparation</a:t>
+            </a:r>
+          </a:p>
+        </p:txBody>
+      </p:sp>
       <p:sp>
         <p:nvSpPr>
           <p:cNvPr id="4" name="TextBox 3"/>
@@ -3609,7 +3563,7 @@
             </a:pPr>
             <a:r>
               <a:rPr sz="1800"/>
-              <a:t>•  CM5 seated on the Compute Module 5 IO Board</a:t>
+              <a:t>•  47 US sign classes narrowed to the 12 the car needs</a:t>
             </a:r>
           </a:p>
           <a:p>
@@ -3620,7 +3574,7 @@
             </a:pPr>
             <a:r>
               <a:rPr sz="1800"/>
-              <a:t>•  Heatsink + PWM fan, CR2032 RTC cell, 128 GB NVMe SSD in the M.2 slot</a:t>
+              <a:t>•  6,097 cropped signs: 4,946 train / 567 validation / 584 test</a:t>
             </a:r>
           </a:p>
           <a:p>
@@ -3631,7 +3585,7 @@
             </a:pPr>
             <a:r>
               <a:rPr sz="1800"/>
-              <a:t>•  Powered by the 27 W USB-C supply; boots Raspberry Pi OS Lite (64-bit) from NVMe</a:t>
+              <a:t>•  Frames of the same sign kept in one split to prevent leakage</a:t>
             </a:r>
           </a:p>
           <a:p>
@@ -3642,151 +3596,14 @@
             </a:pPr>
             <a:r>
               <a:rPr sz="1800"/>
-              <a:t>•  Accessed headless over SSH through the USB Wi-Fi dongle</a:t>
-            </a:r>
-          </a:p>
-        </p:txBody>
-      </p:sp>
-    </p:spTree>
-  </p:cSld>
-  <p:clrMapOvr>
-    <a:masterClrMapping/>
-  </p:clrMapOvr>
-</p:sld>
-</file>
-
-<file path=ppt/slides/slide3.xml><?xml version="1.0" encoding="utf-8"?>
-<p:sld xmlns:a="http://schemas.openxmlformats.org/drawingml/2006/main" xmlns:r="http://schemas.openxmlformats.org/officeDocument/2006/relationships" xmlns:p="http://schemas.openxmlformats.org/presentationml/2006/main">
-  <p:cSld>
-    <p:spTree>
-      <p:nvGrpSpPr>
-        <p:cNvPr id="1" name=""/>
-        <p:cNvGrpSpPr/>
-        <p:nvPr/>
-      </p:nvGrpSpPr>
-      <p:grpSpPr>
-        <a:xfrm>
-          <a:off x="0" y="0"/>
-          <a:ext cx="0" cy="0"/>
-          <a:chOff x="0" y="0"/>
-          <a:chExt cx="0" cy="0"/>
-        </a:xfrm>
-      </p:grpSpPr>
-      <p:sp>
-        <p:nvSpPr>
-          <p:cNvPr id="2" name="Title 1"/>
-          <p:cNvSpPr>
-            <a:spLocks noGrp="1"/>
-          </p:cNvSpPr>
-          <p:nvPr>
-            <p:ph type="title"/>
-          </p:nvPr>
-        </p:nvSpPr>
-        <p:spPr/>
-        <p:txBody>
-          <a:bodyPr/>
-          <a:lstStyle/>
-          <a:p>
-            <a:r>
-              <a:t>Development Environment Setup</a:t>
-            </a:r>
-          </a:p>
-        </p:txBody>
-      </p:sp>
-      <p:sp>
-        <p:nvSpPr>
-          <p:cNvPr id="4" name="TextBox 3"/>
-          <p:cNvSpPr txBox="1"/>
-          <p:nvPr/>
-        </p:nvSpPr>
-        <p:spPr>
-          <a:xfrm>
-            <a:off x="6400800" y="1920240"/>
-            <a:ext cx="5303520" cy="2970044"/>
-          </a:xfrm>
-          <a:prstGeom prst="rect">
-            <a:avLst/>
-          </a:prstGeom>
-          <a:noFill/>
-        </p:spPr>
-        <p:txBody>
-          <a:bodyPr wrap="square">
-            <a:spAutoFit/>
-          </a:bodyPr>
-          <a:lstStyle/>
-          <a:p>
-            <a:pPr>
-              <a:spcAft>
-                <a:spcPts val="1000"/>
-              </a:spcAft>
-            </a:pPr>
-            <a:r>
-              <a:rPr sz="1800" dirty="0"/>
-              <a:t>•  Wrote </a:t>
-            </a:r>
-            <a:r>
-              <a:rPr sz="1800" dirty="0" err="1"/>
-              <a:t>setup.sh</a:t>
-            </a:r>
-            <a:r>
-              <a:rPr sz="1800" dirty="0"/>
-              <a:t> so </a:t>
-            </a:r>
-            <a:r>
-              <a:rPr lang="en-US" sz="1800" dirty="0"/>
-              <a:t>anyone </a:t>
-            </a:r>
-            <a:r>
-              <a:rPr sz="1800" dirty="0"/>
-              <a:t>can bring a board to the same baseline with one command</a:t>
-            </a:r>
-          </a:p>
-          <a:p>
-            <a:pPr>
-              <a:spcAft>
-                <a:spcPts val="1000"/>
-              </a:spcAft>
-            </a:pPr>
-            <a:r>
-              <a:rPr sz="1800" dirty="0"/>
-              <a:t>•  Installs the shared prerequisites: git, python3, pip, and </a:t>
-            </a:r>
-            <a:r>
-              <a:rPr sz="1800" dirty="0" err="1"/>
-              <a:t>venv</a:t>
-            </a:r>
-            <a:r>
-              <a:rPr lang="en-US" sz="1800" dirty="0"/>
-              <a:t> </a:t>
-            </a:r>
-          </a:p>
-          <a:p>
-            <a:pPr>
-              <a:spcAft>
-                <a:spcPts val="1000"/>
-              </a:spcAft>
-            </a:pPr>
-            <a:r>
-              <a:rPr sz="1800" dirty="0"/>
-              <a:t>•  Prints the git and python3 versions at the end to confirm the install worked</a:t>
-            </a:r>
-          </a:p>
-          <a:p>
-            <a:pPr>
-              <a:spcAft>
-                <a:spcPts val="1000"/>
-              </a:spcAft>
-            </a:pPr>
-            <a:r>
-              <a:rPr sz="1800" dirty="0"/>
-              <a:t>•  Hardware-specific and runtime libraries (camera, GPIO, TensorFlow Lite) get added as the project needs them</a:t>
+              <a:t>•  Every class is present in all three splits</a:t>
             </a:r>
           </a:p>
         </p:txBody>
       </p:sp>
       <p:pic>
         <p:nvPicPr>
-          <p:cNvPr id="5" name="Picture 4" descr="setup_sh.png"/>
+          <p:cNvPr id="5" name="Picture 4" descr="lisa_classes.png"/>
           <p:cNvPicPr>
             <a:picLocks noChangeAspect="1"/>
           </p:cNvPicPr>
@@ -3800,14 +3617,233 @@
         </p:blipFill>
         <p:spPr>
           <a:xfrm>
-            <a:off x="548640" y="2103120"/>
-            <a:ext cx="5486400" cy="3266902"/>
+            <a:off x="841937" y="1737360"/>
+            <a:ext cx="4690445" cy="4114800"/>
           </a:xfrm>
           <a:prstGeom prst="rect">
             <a:avLst/>
           </a:prstGeom>
         </p:spPr>
       </p:pic>
+    </p:spTree>
+  </p:cSld>
+  <p:clrMapOvr>
+    <a:masterClrMapping/>
+  </p:clrMapOvr>
+</p:sld>
+</file>
+
+<file path=ppt/slides/slide3.xml><?xml version="1.0" encoding="utf-8"?>
+<p:sld xmlns:a="http://schemas.openxmlformats.org/drawingml/2006/main" xmlns:p="http://schemas.openxmlformats.org/presentationml/2006/main" xmlns:r="http://schemas.openxmlformats.org/officeDocument/2006/relationships">
+  <p:cSld>
+    <p:spTree>
+      <p:nvGrpSpPr>
+        <p:cNvPr id="1" name=""/>
+        <p:cNvGrpSpPr/>
+        <p:nvPr/>
+      </p:nvGrpSpPr>
+      <p:grpSpPr/>
+      <p:sp>
+        <p:nvSpPr>
+          <p:cNvPr id="2" name="Title 1"/>
+          <p:cNvSpPr>
+            <a:spLocks noGrp="1"/>
+          </p:cNvSpPr>
+          <p:nvPr>
+            <p:ph type="title"/>
+          </p:nvPr>
+        </p:nvSpPr>
+        <p:spPr/>
+        <p:txBody>
+          <a:bodyPr/>
+          <a:lstStyle/>
+          <a:p>
+            <a:r>
+              <a:t>GTSRB Test Results</a:t>
+            </a:r>
+          </a:p>
+        </p:txBody>
+      </p:sp>
+      <p:sp>
+        <p:nvSpPr>
+          <p:cNvPr id="3" name="TextBox 2"/>
+          <p:cNvSpPr txBox="1"/>
+          <p:nvPr/>
+        </p:nvSpPr>
+        <p:spPr>
+          <a:xfrm>
+            <a:off x="548640" y="1920240"/>
+            <a:ext cx="5577840" cy="2560320"/>
+          </a:xfrm>
+          <a:prstGeom prst="rect">
+            <a:avLst/>
+          </a:prstGeom>
+          <a:solidFill>
+            <a:srgbClr val="F3F3F3"/>
+          </a:solidFill>
+          <a:ln>
+            <a:solidFill>
+              <a:srgbClr val="BFBFBF"/>
+            </a:solidFill>
+          </a:ln>
+        </p:spPr>
+        <p:txBody>
+          <a:bodyPr wrap="square" lIns="182880" rIns="182880" tIns="182880" bIns="182880">
+            <a:spAutoFit/>
+          </a:bodyPr>
+          <a:lstStyle/>
+          <a:p>
+            <a:r>
+              <a:rPr sz="1400" b="1">
+                <a:solidFill>
+                  <a:srgbClr val="595959"/>
+                </a:solidFill>
+                <a:latin typeface="Menlo"/>
+              </a:rPr>
+              <a:t>gtsrb_test_results.json</a:t>
+            </a:r>
+          </a:p>
+          <a:p>
+            <a:r>
+              <a:rPr sz="1400">
+                <a:latin typeface="Menlo"/>
+              </a:rPr>
+              <a:t>{</a:t>
+            </a:r>
+          </a:p>
+          <a:p>
+            <a:r>
+              <a:rPr sz="1400">
+                <a:latin typeface="Menlo"/>
+              </a:rPr>
+              <a:t>  "images": 12630,</a:t>
+            </a:r>
+          </a:p>
+          <a:p>
+            <a:r>
+              <a:rPr sz="1400">
+                <a:latin typeface="Menlo"/>
+              </a:rPr>
+              <a:t>  "top1_accuracy": 0.9578780680918448,</a:t>
+            </a:r>
+          </a:p>
+          <a:p>
+            <a:r>
+              <a:rPr sz="1400">
+                <a:latin typeface="Menlo"/>
+              </a:rPr>
+              <a:t>  "top3_accuracy": 0.9844813935075217,</a:t>
+            </a:r>
+          </a:p>
+          <a:p>
+            <a:r>
+              <a:rPr sz="1400">
+                <a:latin typeface="Menlo"/>
+              </a:rPr>
+              <a:t>  "macro_class_accuracy": 0.9383357305447801,</a:t>
+            </a:r>
+          </a:p>
+          <a:p>
+            <a:r>
+              <a:rPr sz="1400">
+                <a:latin typeface="Menlo"/>
+              </a:rPr>
+              <a:t>  "correct": 12098,</a:t>
+            </a:r>
+          </a:p>
+          <a:p>
+            <a:r>
+              <a:rPr sz="1400">
+                <a:latin typeface="Menlo"/>
+              </a:rPr>
+              <a:t>  "incorrect": 532,</a:t>
+            </a:r>
+          </a:p>
+          <a:p>
+            <a:r>
+              <a:rPr sz="1400">
+                <a:latin typeface="Menlo"/>
+              </a:rPr>
+              <a:t>  "per_class": { ... }</a:t>
+            </a:r>
+          </a:p>
+          <a:p>
+            <a:r>
+              <a:rPr sz="1400">
+                <a:latin typeface="Menlo"/>
+              </a:rPr>
+              <a:t>}</a:t>
+            </a:r>
+          </a:p>
+        </p:txBody>
+      </p:sp>
+      <p:sp>
+        <p:nvSpPr>
+          <p:cNvPr id="4" name="TextBox 3"/>
+          <p:cNvSpPr txBox="1"/>
+          <p:nvPr/>
+        </p:nvSpPr>
+        <p:spPr>
+          <a:xfrm>
+            <a:off x="6309360" y="1920240"/>
+            <a:ext cx="5394960" cy="3657600"/>
+          </a:xfrm>
+          <a:prstGeom prst="rect">
+            <a:avLst/>
+          </a:prstGeom>
+          <a:noFill/>
+        </p:spPr>
+        <p:txBody>
+          <a:bodyPr wrap="square">
+            <a:spAutoFit/>
+          </a:bodyPr>
+          <a:lstStyle/>
+          <a:p>
+            <a:pPr>
+              <a:spcAft>
+                <a:spcPts val="1000"/>
+              </a:spcAft>
+            </a:pPr>
+            <a:r>
+              <a:rPr sz="1800"/>
+              <a:t>•  12,630 test images the model never saw during training</a:t>
+            </a:r>
+          </a:p>
+          <a:p>
+            <a:pPr>
+              <a:spcAft>
+                <a:spcPts val="1000"/>
+              </a:spcAft>
+            </a:pPr>
+            <a:r>
+              <a:rPr sz="1800"/>
+              <a:t>•  95.8% top-1: 12,098 correct, 532 incorrect</a:t>
+            </a:r>
+          </a:p>
+          <a:p>
+            <a:pPr>
+              <a:spcAft>
+                <a:spcPts val="1000"/>
+              </a:spcAft>
+            </a:pPr>
+            <a:r>
+              <a:rPr sz="1800"/>
+              <a:t>•  98.4% top-3: the right sign is in the model's top 3 guesses</a:t>
+            </a:r>
+          </a:p>
+          <a:p>
+            <a:pPr>
+              <a:spcAft>
+                <a:spcPts val="1000"/>
+              </a:spcAft>
+            </a:pPr>
+            <a:r>
+              <a:rPr sz="1800"/>
+              <a:t>•  93.8% macro: accuracy averaged across all 43 sign classes</a:t>
+            </a:r>
+          </a:p>
+        </p:txBody>
+      </p:sp>
     </p:spTree>
   </p:cSld>
   <p:clrMapOvr>

</xml_diff>